<commit_message>
data-eng 5-2 덱 5(w5d2s0 신설)·묶음
</commit_message>
<xml_diff>
--- a/data-eng/decks/w5d2s1.pptx
+++ b/data-eng/decks/w5d2s1.pptx
@@ -3100,7 +3100,7 @@
       <p:grpSpPr/>
       <p:sp>
         <p:nvSpPr>
-          <p:cNvPr id="2" name="Oval 1"/>
+          <p:cNvPr id="2" name="deckgen:decor"/>
           <p:cNvSpPr/>
           <p:nvPr/>
         </p:nvSpPr>
@@ -3130,7 +3130,7 @@
       </p:sp>
       <p:sp>
         <p:nvSpPr>
-          <p:cNvPr id="3" name="Oval 2"/>
+          <p:cNvPr id="3" name="deckgen:decor"/>
           <p:cNvSpPr/>
           <p:nvPr/>
         </p:nvSpPr>
@@ -3160,7 +3160,7 @@
       </p:sp>
       <p:sp>
         <p:nvSpPr>
-          <p:cNvPr id="4" name="Oval 3"/>
+          <p:cNvPr id="4" name="deckgen:decor"/>
           <p:cNvSpPr/>
           <p:nvPr/>
         </p:nvSpPr>
@@ -3190,7 +3190,7 @@
       </p:sp>
       <p:sp>
         <p:nvSpPr>
-          <p:cNvPr id="5" name="Rectangle 4"/>
+          <p:cNvPr id="5" name="deckgen:decor"/>
           <p:cNvSpPr/>
           <p:nvPr/>
         </p:nvSpPr>
@@ -3220,7 +3220,7 @@
       </p:sp>
       <p:sp>
         <p:nvSpPr>
-          <p:cNvPr id="6" name="Oval 5"/>
+          <p:cNvPr id="6" name="deckgen:decor"/>
           <p:cNvSpPr/>
           <p:nvPr/>
         </p:nvSpPr>
@@ -3250,7 +3250,7 @@
       </p:sp>
       <p:sp>
         <p:nvSpPr>
-          <p:cNvPr id="7" name="Oval 6"/>
+          <p:cNvPr id="7" name="deckgen:decor"/>
           <p:cNvSpPr/>
           <p:nvPr/>
         </p:nvSpPr>
@@ -3280,7 +3280,7 @@
       </p:sp>
       <p:sp>
         <p:nvSpPr>
-          <p:cNvPr id="8" name="Oval 7"/>
+          <p:cNvPr id="8" name="deckgen:decor"/>
           <p:cNvSpPr/>
           <p:nvPr/>
         </p:nvSpPr>
@@ -3310,7 +3310,7 @@
       </p:sp>
       <p:sp>
         <p:nvSpPr>
-          <p:cNvPr id="9" name="Oval 8"/>
+          <p:cNvPr id="9" name="deckgen:decor"/>
           <p:cNvSpPr/>
           <p:nvPr/>
         </p:nvSpPr>
@@ -3340,7 +3340,7 @@
       </p:sp>
       <p:sp>
         <p:nvSpPr>
-          <p:cNvPr id="10" name="Rectangle 9"/>
+          <p:cNvPr id="10" name="deckgen:decor"/>
           <p:cNvSpPr/>
           <p:nvPr/>
         </p:nvSpPr>
@@ -3600,7 +3600,7 @@
       <p:grpSpPr/>
       <p:sp>
         <p:nvSpPr>
-          <p:cNvPr id="2" name="Oval 1"/>
+          <p:cNvPr id="2" name="deckgen:decor"/>
           <p:cNvSpPr/>
           <p:nvPr/>
         </p:nvSpPr>
@@ -3630,7 +3630,7 @@
       </p:sp>
       <p:sp>
         <p:nvSpPr>
-          <p:cNvPr id="3" name="Oval 2"/>
+          <p:cNvPr id="3" name="deckgen:decor"/>
           <p:cNvSpPr/>
           <p:nvPr/>
         </p:nvSpPr>
@@ -3660,7 +3660,7 @@
       </p:sp>
       <p:sp>
         <p:nvSpPr>
-          <p:cNvPr id="4" name="Oval 3"/>
+          <p:cNvPr id="4" name="deckgen:decor"/>
           <p:cNvSpPr/>
           <p:nvPr/>
         </p:nvSpPr>
@@ -4662,7 +4662,7 @@
       <p:grpSpPr/>
       <p:sp>
         <p:nvSpPr>
-          <p:cNvPr id="2" name="Oval 1"/>
+          <p:cNvPr id="2" name="deckgen:decor"/>
           <p:cNvSpPr/>
           <p:nvPr/>
         </p:nvSpPr>
@@ -4692,7 +4692,7 @@
       </p:sp>
       <p:sp>
         <p:nvSpPr>
-          <p:cNvPr id="3" name="Oval 2"/>
+          <p:cNvPr id="3" name="deckgen:decor"/>
           <p:cNvSpPr/>
           <p:nvPr/>
         </p:nvSpPr>
@@ -4984,7 +4984,7 @@
                 <a:ea typeface="Pretendard"/>
                 <a:cs typeface="Pretendard"/>
               </a:rPr>
-              <a:t>8080 포트 비우기 · compose 파일 작성</a:t>
+              <a:t>compose 파일 작성 · up -d · ps</a:t>
             </a:r>
           </a:p>
         </p:txBody>
@@ -5100,7 +5100,7 @@
                 <a:ea typeface="Pretendard"/>
                 <a:cs typeface="Pretendard"/>
               </a:rPr>
-              <a:t>docker compose up -d · ps</a:t>
+              <a:t>로그에서 Registering worker 찾기</a:t>
             </a:r>
           </a:p>
         </p:txBody>
@@ -5216,7 +5216,7 @@
                 <a:ea typeface="Pretendard"/>
                 <a:cs typeface="Pretendard"/>
               </a:rPr>
-              <a:t>로그에서 Registering worker 찾기</a:t>
+              <a:t>--scale 로 워커 늘렸다 줄이기</a:t>
             </a:r>
           </a:p>
         </p:txBody>
@@ -5332,7 +5332,7 @@
                 <a:ea typeface="Pretendard"/>
                 <a:cs typeface="Pretendard"/>
               </a:rPr>
-              <a:t>--scale 로 워커 늘렸다 줄이기</a:t>
+              <a:t>마스터를 껐다 켜기 (일부러 실패)</a:t>
             </a:r>
           </a:p>
         </p:txBody>
@@ -5444,7 +5444,7 @@
                 <a:ea typeface="Pretendard"/>
                 <a:cs typeface="Pretendard"/>
               </a:rPr>
-              <a:t>Docker Desktop 실행 · 5-1 컨테이너 종료</a:t>
+              <a:t>~/lakehouse stop · 8080 비우기</a:t>
             </a:r>
           </a:p>
         </p:txBody>
@@ -5469,7 +5469,7 @@
       <p:grpSpPr/>
       <p:sp>
         <p:nvSpPr>
-          <p:cNvPr id="2" name="Oval 1"/>
+          <p:cNvPr id="2" name="deckgen:decor"/>
           <p:cNvSpPr/>
           <p:nvPr/>
         </p:nvSpPr>
@@ -5499,7 +5499,7 @@
       </p:sp>
       <p:sp>
         <p:nvSpPr>
-          <p:cNvPr id="3" name="Oval 2"/>
+          <p:cNvPr id="3" name="deckgen:decor"/>
           <p:cNvSpPr/>
           <p:nvPr/>
         </p:nvSpPr>
@@ -5529,7 +5529,7 @@
       </p:sp>
       <p:sp>
         <p:nvSpPr>
-          <p:cNvPr id="4" name="Oval 3"/>
+          <p:cNvPr id="4" name="deckgen:decor"/>
           <p:cNvSpPr/>
           <p:nvPr/>
         </p:nvSpPr>
@@ -6460,7 +6460,7 @@
       <p:grpSpPr/>
       <p:sp>
         <p:nvSpPr>
-          <p:cNvPr id="2" name="Oval 1"/>
+          <p:cNvPr id="2" name="deckgen:decor"/>
           <p:cNvSpPr/>
           <p:nvPr/>
         </p:nvSpPr>
@@ -6490,7 +6490,7 @@
       </p:sp>
       <p:sp>
         <p:nvSpPr>
-          <p:cNvPr id="3" name="Oval 2"/>
+          <p:cNvPr id="3" name="deckgen:decor"/>
           <p:cNvSpPr/>
           <p:nvPr/>
         </p:nvSpPr>
@@ -6520,7 +6520,7 @@
       </p:sp>
       <p:sp>
         <p:nvSpPr>
-          <p:cNvPr id="4" name="Oval 3"/>
+          <p:cNvPr id="4" name="deckgen:decor"/>
           <p:cNvSpPr/>
           <p:nvPr/>
         </p:nvSpPr>
@@ -8317,7 +8317,7 @@
       <p:grpSpPr/>
       <p:sp>
         <p:nvSpPr>
-          <p:cNvPr id="2" name="Oval 1"/>
+          <p:cNvPr id="2" name="deckgen:decor"/>
           <p:cNvSpPr/>
           <p:nvPr/>
         </p:nvSpPr>
@@ -8347,7 +8347,7 @@
       </p:sp>
       <p:sp>
         <p:nvSpPr>
-          <p:cNvPr id="3" name="Oval 2"/>
+          <p:cNvPr id="3" name="deckgen:decor"/>
           <p:cNvSpPr/>
           <p:nvPr/>
         </p:nvSpPr>
@@ -8377,7 +8377,7 @@
       </p:sp>
       <p:sp>
         <p:nvSpPr>
-          <p:cNvPr id="4" name="Oval 3"/>
+          <p:cNvPr id="4" name="deckgen:decor"/>
           <p:cNvSpPr/>
           <p:nvPr/>
         </p:nvSpPr>
@@ -9378,7 +9378,7 @@
       <p:grpSpPr/>
       <p:sp>
         <p:nvSpPr>
-          <p:cNvPr id="2" name="Oval 1"/>
+          <p:cNvPr id="2" name="deckgen:decor"/>
           <p:cNvSpPr/>
           <p:nvPr/>
         </p:nvSpPr>
@@ -9408,7 +9408,7 @@
       </p:sp>
       <p:sp>
         <p:nvSpPr>
-          <p:cNvPr id="3" name="Oval 2"/>
+          <p:cNvPr id="3" name="deckgen:decor"/>
           <p:cNvSpPr/>
           <p:nvPr/>
         </p:nvSpPr>
@@ -9438,7 +9438,7 @@
       </p:sp>
       <p:sp>
         <p:nvSpPr>
-          <p:cNvPr id="4" name="Oval 3"/>
+          <p:cNvPr id="4" name="deckgen:decor"/>
           <p:cNvSpPr/>
           <p:nvPr/>
         </p:nvSpPr>
@@ -10885,7 +10885,7 @@
       <p:grpSpPr/>
       <p:sp>
         <p:nvSpPr>
-          <p:cNvPr id="2" name="Oval 1"/>
+          <p:cNvPr id="2" name="deckgen:decor"/>
           <p:cNvSpPr/>
           <p:nvPr/>
         </p:nvSpPr>
@@ -10915,7 +10915,7 @@
       </p:sp>
       <p:sp>
         <p:nvSpPr>
-          <p:cNvPr id="3" name="Oval 2"/>
+          <p:cNvPr id="3" name="deckgen:decor"/>
           <p:cNvSpPr/>
           <p:nvPr/>
         </p:nvSpPr>
@@ -10945,7 +10945,7 @@
       </p:sp>
       <p:sp>
         <p:nvSpPr>
-          <p:cNvPr id="4" name="Oval 3"/>
+          <p:cNvPr id="4" name="deckgen:decor"/>
           <p:cNvSpPr/>
           <p:nvPr/>
         </p:nvSpPr>
@@ -12371,7 +12371,7 @@
       <p:grpSpPr/>
       <p:sp>
         <p:nvSpPr>
-          <p:cNvPr id="2" name="Oval 1"/>
+          <p:cNvPr id="2" name="deckgen:decor"/>
           <p:cNvSpPr/>
           <p:nvPr/>
         </p:nvSpPr>
@@ -12401,7 +12401,7 @@
       </p:sp>
       <p:sp>
         <p:nvSpPr>
-          <p:cNvPr id="3" name="Oval 2"/>
+          <p:cNvPr id="3" name="deckgen:decor"/>
           <p:cNvSpPr/>
           <p:nvPr/>
         </p:nvSpPr>
@@ -12431,7 +12431,7 @@
       </p:sp>
       <p:sp>
         <p:nvSpPr>
-          <p:cNvPr id="4" name="Oval 3"/>
+          <p:cNvPr id="4" name="deckgen:decor"/>
           <p:cNvSpPr/>
           <p:nvPr/>
         </p:nvSpPr>
@@ -12936,7 +12936,7 @@
                 <a:ea typeface="Pretendard"/>
                 <a:cs typeface="Pretendard"/>
               </a:rPr>
-              <a:t>cluster 모드 — 운영 배치</a:t>
+              <a:t>cluster 모드 — 오늘은 못 씀</a:t>
             </a:r>
           </a:p>
         </p:txBody>
@@ -13082,7 +13082,7 @@
                 <a:ea typeface="Pretendard"/>
                 <a:cs typeface="Pretendard"/>
               </a:rPr>
-              <a:t>로그는 클러스터 로그를 봐야 한다</a:t>
+              <a:t>터미널을 닫아도 계속 돈다</a:t>
             </a:r>
           </a:p>
         </p:txBody>
@@ -13153,7 +13153,7 @@
                 <a:ea typeface="Pretendard"/>
                 <a:cs typeface="Pretendard"/>
               </a:rPr>
-              <a:t>터미널을 닫아도 계속 돈다</a:t>
+              <a:t>파이썬 앱은 Standalone 에서 불가(실측)</a:t>
             </a:r>
           </a:p>
         </p:txBody>
@@ -13224,7 +13224,7 @@
                 <a:ea typeface="Pretendard"/>
                 <a:cs typeface="Pretendard"/>
               </a:rPr>
-              <a:t>8주차 Airflow 스케줄링 때 쓴다</a:t>
+              <a:t>YARN · Kubernetes 같은 매니저에서 쓴다</a:t>
             </a:r>
           </a:p>
         </p:txBody>
@@ -13432,7 +13432,7 @@
       <p:grpSpPr/>
       <p:sp>
         <p:nvSpPr>
-          <p:cNvPr id="2" name="Oval 1"/>
+          <p:cNvPr id="2" name="deckgen:decor"/>
           <p:cNvSpPr/>
           <p:nvPr/>
         </p:nvSpPr>
@@ -13462,7 +13462,7 @@
       </p:sp>
       <p:sp>
         <p:nvSpPr>
-          <p:cNvPr id="3" name="Oval 2"/>
+          <p:cNvPr id="3" name="deckgen:decor"/>
           <p:cNvSpPr/>
           <p:nvPr/>
         </p:nvSpPr>
@@ -13492,7 +13492,7 @@
       </p:sp>
       <p:sp>
         <p:nvSpPr>
-          <p:cNvPr id="4" name="Oval 3"/>
+          <p:cNvPr id="4" name="deckgen:decor"/>
           <p:cNvSpPr/>
           <p:nvPr/>
         </p:nvSpPr>
@@ -14459,7 +14459,7 @@
       <p:grpSpPr/>
       <p:sp>
         <p:nvSpPr>
-          <p:cNvPr id="2" name="Oval 1"/>
+          <p:cNvPr id="2" name="deckgen:decor"/>
           <p:cNvSpPr/>
           <p:nvPr/>
         </p:nvSpPr>
@@ -14489,7 +14489,7 @@
       </p:sp>
       <p:sp>
         <p:nvSpPr>
-          <p:cNvPr id="3" name="Oval 2"/>
+          <p:cNvPr id="3" name="deckgen:decor"/>
           <p:cNvSpPr/>
           <p:nvPr/>
         </p:nvSpPr>
@@ -14519,7 +14519,7 @@
       </p:sp>
       <p:sp>
         <p:nvSpPr>
-          <p:cNvPr id="4" name="Oval 3"/>
+          <p:cNvPr id="4" name="deckgen:decor"/>
           <p:cNvSpPr/>
           <p:nvPr/>
         </p:nvSpPr>

</xml_diff>